<commit_message>
Draw .ppt hyperlinks in the scheme's hyperlink color, underlined
Linked text ranges (TxInteractiveInfoAtom) were drawn like the text around
them; PowerPoint shows them in the color scheme's hyperlink color with an
underline.
</commit_message>
<xml_diff>
--- a/officecanvas/src/test/resources/pptx_samples/feature_test.pptx
+++ b/officecanvas/src/test/resources/pptx_samples/feature_test.pptx
@@ -3634,6 +3634,18 @@
                 <a:latin typeface="Courier New"/>
               </a:rPr>
               <a:t>mono text</a:t>
+            </a:r>
+          </a:p>
+          <a:p>
+            <a:r>
+              <a:rPr sz="2400"/>
+              <a:t>see </a:t>
+            </a:r>
+            <a:r>
+              <a:rPr sz="2400">
+                <a:hlinkClick r:id="rId4"/>
+              </a:rPr>
+              <a:t>example.org</a:t>
             </a:r>
           </a:p>
         </p:txBody>

</xml_diff>